<commit_message>
Adaptive Archive Size update
</commit_message>
<xml_diff>
--- a/New Implementation.pptx
+++ b/New Implementation.pptx
@@ -5,7 +5,7 @@
     <p:sldMasterId id="2147483648" r:id="rId1"/>
   </p:sldMasterIdLst>
   <p:notesMasterIdLst>
-    <p:notesMasterId r:id="rId10"/>
+    <p:notesMasterId r:id="rId11"/>
   </p:notesMasterIdLst>
   <p:sldIdLst>
     <p:sldId id="256" r:id="rId2"/>
@@ -16,6 +16,7 @@
     <p:sldId id="269" r:id="rId7"/>
     <p:sldId id="261" r:id="rId8"/>
     <p:sldId id="262" r:id="rId9"/>
+    <p:sldId id="270" r:id="rId10"/>
   </p:sldIdLst>
   <p:sldSz cx="12192000" cy="6858000"/>
   <p:notesSz cx="6858000" cy="9144000"/>
@@ -631,6 +632,90 @@
     <p:extLst>
       <p:ext uri="{BB962C8B-B14F-4D97-AF65-F5344CB8AC3E}">
         <p14:creationId xmlns:p14="http://schemas.microsoft.com/office/powerpoint/2010/main" val="637997435"/>
+      </p:ext>
+    </p:extLst>
+  </p:cSld>
+  <p:clrMapOvr>
+    <a:masterClrMapping/>
+  </p:clrMapOvr>
+</p:notes>
+</file>
+
+<file path=ppt/notesSlides/notesSlide3.xml><?xml version="1.0" encoding="utf-8"?>
+<p:notes xmlns:a="http://schemas.openxmlformats.org/drawingml/2006/main" xmlns:r="http://schemas.openxmlformats.org/officeDocument/2006/relationships" xmlns:p="http://schemas.openxmlformats.org/presentationml/2006/main">
+  <p:cSld>
+    <p:spTree>
+      <p:nvGrpSpPr>
+        <p:cNvPr id="1" name=""/>
+        <p:cNvGrpSpPr/>
+        <p:nvPr/>
+      </p:nvGrpSpPr>
+      <p:grpSpPr>
+        <a:xfrm>
+          <a:off x="0" y="0"/>
+          <a:ext cx="0" cy="0"/>
+          <a:chOff x="0" y="0"/>
+          <a:chExt cx="0" cy="0"/>
+        </a:xfrm>
+      </p:grpSpPr>
+      <p:sp>
+        <p:nvSpPr>
+          <p:cNvPr id="2" name="Slide Image Placeholder 1"/>
+          <p:cNvSpPr>
+            <a:spLocks noGrp="1" noRot="1" noChangeAspect="1"/>
+          </p:cNvSpPr>
+          <p:nvPr>
+            <p:ph type="sldImg"/>
+          </p:nvPr>
+        </p:nvSpPr>
+        <p:spPr/>
+      </p:sp>
+      <p:sp>
+        <p:nvSpPr>
+          <p:cNvPr id="3" name="Notes Placeholder 2"/>
+          <p:cNvSpPr>
+            <a:spLocks noGrp="1"/>
+          </p:cNvSpPr>
+          <p:nvPr>
+            <p:ph type="body" idx="1"/>
+          </p:nvPr>
+        </p:nvSpPr>
+        <p:spPr/>
+        <p:txBody>
+          <a:bodyPr/>
+          <a:lstStyle/>
+          <a:p>
+            <a:endParaRPr lang="en-LK" dirty="0"/>
+          </a:p>
+        </p:txBody>
+      </p:sp>
+      <p:sp>
+        <p:nvSpPr>
+          <p:cNvPr id="4" name="Slide Number Placeholder 3"/>
+          <p:cNvSpPr>
+            <a:spLocks noGrp="1"/>
+          </p:cNvSpPr>
+          <p:nvPr>
+            <p:ph type="sldNum" sz="quarter" idx="5"/>
+          </p:nvPr>
+        </p:nvSpPr>
+        <p:spPr/>
+        <p:txBody>
+          <a:bodyPr/>
+          <a:lstStyle/>
+          <a:p>
+            <a:fld id="{BE5D973A-524B-9A4E-B824-03E276179D51}" type="slidenum">
+              <a:rPr lang="en-LK" smtClean="0"/>
+              <a:t>9</a:t>
+            </a:fld>
+            <a:endParaRPr lang="en-LK"/>
+          </a:p>
+        </p:txBody>
+      </p:sp>
+    </p:spTree>
+    <p:extLst>
+      <p:ext uri="{BB962C8B-B14F-4D97-AF65-F5344CB8AC3E}">
+        <p14:creationId xmlns:p14="http://schemas.microsoft.com/office/powerpoint/2010/main" val="3748885860"/>
       </p:ext>
     </p:extLst>
   </p:cSld>
@@ -11782,6 +11867,1448 @@
     <p:extLst>
       <p:ext uri="{BB962C8B-B14F-4D97-AF65-F5344CB8AC3E}">
         <p14:creationId xmlns:p14="http://schemas.microsoft.com/office/powerpoint/2010/main" val="3456060199"/>
+      </p:ext>
+    </p:extLst>
+  </p:cSld>
+  <p:clrMapOvr>
+    <a:masterClrMapping/>
+  </p:clrMapOvr>
+</p:sld>
+</file>
+
+<file path=ppt/slides/slide9.xml><?xml version="1.0" encoding="utf-8"?>
+<p:sld xmlns:a="http://schemas.openxmlformats.org/drawingml/2006/main" xmlns:r="http://schemas.openxmlformats.org/officeDocument/2006/relationships" xmlns:p="http://schemas.openxmlformats.org/presentationml/2006/main">
+  <p:cSld>
+    <p:spTree>
+      <p:nvGrpSpPr>
+        <p:cNvPr id="1" name=""/>
+        <p:cNvGrpSpPr/>
+        <p:nvPr/>
+      </p:nvGrpSpPr>
+      <p:grpSpPr>
+        <a:xfrm>
+          <a:off x="0" y="0"/>
+          <a:ext cx="0" cy="0"/>
+          <a:chOff x="0" y="0"/>
+          <a:chExt cx="0" cy="0"/>
+        </a:xfrm>
+      </p:grpSpPr>
+      <p:sp>
+        <p:nvSpPr>
+          <p:cNvPr id="4" name="矩形 11">
+            <a:extLst>
+              <a:ext uri="{FF2B5EF4-FFF2-40B4-BE49-F238E27FC236}">
+                <a16:creationId xmlns:a16="http://schemas.microsoft.com/office/drawing/2014/main" id="{7DE3C627-6ED9-B5CF-C82E-688FD05DFF33}"/>
+              </a:ext>
+            </a:extLst>
+          </p:cNvPr>
+          <p:cNvSpPr/>
+          <p:nvPr/>
+        </p:nvSpPr>
+        <p:spPr>
+          <a:xfrm>
+            <a:off x="0" y="0"/>
+            <a:ext cx="12192000" cy="6858000"/>
+          </a:xfrm>
+          <a:prstGeom prst="rect">
+            <a:avLst/>
+          </a:prstGeom>
+          <a:gradFill>
+            <a:gsLst>
+              <a:gs pos="19000">
+                <a:schemeClr val="accent1">
+                  <a:lumMod val="5000"/>
+                  <a:lumOff val="95000"/>
+                  <a:alpha val="90000"/>
+                </a:schemeClr>
+              </a:gs>
+              <a:gs pos="59000">
+                <a:schemeClr val="accent1">
+                  <a:lumMod val="30000"/>
+                  <a:lumOff val="70000"/>
+                  <a:alpha val="95000"/>
+                </a:schemeClr>
+              </a:gs>
+            </a:gsLst>
+            <a:lin ang="2700000" scaled="0"/>
+          </a:gradFill>
+          <a:ln>
+            <a:noFill/>
+          </a:ln>
+        </p:spPr>
+        <p:style>
+          <a:lnRef idx="2">
+            <a:schemeClr val="accent1">
+              <a:shade val="15000"/>
+            </a:schemeClr>
+          </a:lnRef>
+          <a:fillRef idx="1">
+            <a:schemeClr val="accent1"/>
+          </a:fillRef>
+          <a:effectRef idx="0">
+            <a:schemeClr val="accent1"/>
+          </a:effectRef>
+          <a:fontRef idx="minor">
+            <a:schemeClr val="lt1"/>
+          </a:fontRef>
+        </p:style>
+        <p:txBody>
+          <a:bodyPr rtlCol="0" anchor="ctr"/>
+          <a:lstStyle/>
+          <a:p>
+            <a:pPr algn="ctr"/>
+            <a:endParaRPr lang="zh-CN" altLang="en-US" dirty="0">
+              <a:solidFill>
+                <a:schemeClr val="tx1"/>
+              </a:solidFill>
+            </a:endParaRPr>
+          </a:p>
+        </p:txBody>
+      </p:sp>
+      <p:pic>
+        <p:nvPicPr>
+          <p:cNvPr id="5" name="图片 122">
+            <a:extLst>
+              <a:ext uri="{FF2B5EF4-FFF2-40B4-BE49-F238E27FC236}">
+                <a16:creationId xmlns:a16="http://schemas.microsoft.com/office/drawing/2014/main" id="{88C03220-CA52-8B62-8455-9AE6F73EA049}"/>
+              </a:ext>
+            </a:extLst>
+          </p:cNvPr>
+          <p:cNvPicPr>
+            <a:picLocks noChangeAspect="1"/>
+          </p:cNvPicPr>
+          <p:nvPr/>
+        </p:nvPicPr>
+        <p:blipFill>
+          <a:blip r:embed="rId3"/>
+          <a:stretch>
+            <a:fillRect/>
+          </a:stretch>
+        </p:blipFill>
+        <p:spPr>
+          <a:xfrm>
+            <a:off x="9553686" y="51450"/>
+            <a:ext cx="2600559" cy="483722"/>
+          </a:xfrm>
+          <a:prstGeom prst="rect">
+            <a:avLst/>
+          </a:prstGeom>
+        </p:spPr>
+      </p:pic>
+      <p:sp>
+        <p:nvSpPr>
+          <p:cNvPr id="2" name="TextBox 1">
+            <a:extLst>
+              <a:ext uri="{FF2B5EF4-FFF2-40B4-BE49-F238E27FC236}">
+                <a16:creationId xmlns:a16="http://schemas.microsoft.com/office/drawing/2014/main" id="{7D6A1267-9557-5765-75FF-F1A4BEA11588}"/>
+              </a:ext>
+            </a:extLst>
+          </p:cNvPr>
+          <p:cNvSpPr txBox="1"/>
+          <p:nvPr/>
+        </p:nvSpPr>
+        <p:spPr>
+          <a:xfrm>
+            <a:off x="-356230" y="483722"/>
+            <a:ext cx="7970954" cy="584775"/>
+          </a:xfrm>
+          <a:prstGeom prst="rect">
+            <a:avLst/>
+          </a:prstGeom>
+          <a:noFill/>
+        </p:spPr>
+        <p:txBody>
+          <a:bodyPr wrap="square" rtlCol="0">
+            <a:spAutoFit/>
+          </a:bodyPr>
+          <a:lstStyle/>
+          <a:p>
+            <a:pPr algn="ctr"/>
+            <a:r>
+              <a:rPr lang="en-US" sz="3200" b="1" dirty="0">
+                <a:effectLst/>
+                <a:latin typeface="+mj-lt"/>
+              </a:rPr>
+              <a:t>Results as for the implementation</a:t>
+            </a:r>
+            <a:endParaRPr lang="en-LK" sz="3200" dirty="0">
+              <a:latin typeface="+mj-lt"/>
+            </a:endParaRPr>
+          </a:p>
+        </p:txBody>
+      </p:sp>
+      <p:pic>
+        <p:nvPicPr>
+          <p:cNvPr id="8" name="Picture 7">
+            <a:extLst>
+              <a:ext uri="{FF2B5EF4-FFF2-40B4-BE49-F238E27FC236}">
+                <a16:creationId xmlns:a16="http://schemas.microsoft.com/office/drawing/2014/main" id="{C4DFEFEF-8F15-C86D-EC47-761B820909CD}"/>
+              </a:ext>
+            </a:extLst>
+          </p:cNvPr>
+          <p:cNvPicPr>
+            <a:picLocks noChangeAspect="1"/>
+          </p:cNvPicPr>
+          <p:nvPr/>
+        </p:nvPicPr>
+        <p:blipFill>
+          <a:blip r:embed="rId4"/>
+          <a:stretch>
+            <a:fillRect/>
+          </a:stretch>
+        </p:blipFill>
+        <p:spPr>
+          <a:xfrm>
+            <a:off x="6860158" y="483722"/>
+            <a:ext cx="4007651" cy="6322828"/>
+          </a:xfrm>
+          <a:prstGeom prst="rect">
+            <a:avLst/>
+          </a:prstGeom>
+        </p:spPr>
+      </p:pic>
+      <p:graphicFrame>
+        <p:nvGraphicFramePr>
+          <p:cNvPr id="51" name="Table 50">
+            <a:extLst>
+              <a:ext uri="{FF2B5EF4-FFF2-40B4-BE49-F238E27FC236}">
+                <a16:creationId xmlns:a16="http://schemas.microsoft.com/office/drawing/2014/main" id="{299FB54A-7234-ED4D-208D-136ADD213A69}"/>
+              </a:ext>
+            </a:extLst>
+          </p:cNvPr>
+          <p:cNvGraphicFramePr>
+            <a:graphicFrameLocks noGrp="1"/>
+          </p:cNvGraphicFramePr>
+          <p:nvPr>
+            <p:extLst>
+              <p:ext uri="{D42A27DB-BD31-4B8C-83A1-F6EECF244321}">
+                <p14:modId xmlns:p14="http://schemas.microsoft.com/office/powerpoint/2010/main" val="1540578704"/>
+              </p:ext>
+            </p:extLst>
+          </p:nvPr>
+        </p:nvGraphicFramePr>
+        <p:xfrm>
+          <a:off x="852378" y="3909060"/>
+          <a:ext cx="4875027" cy="2468880"/>
+        </p:xfrm>
+        <a:graphic>
+          <a:graphicData uri="http://schemas.openxmlformats.org/drawingml/2006/table">
+            <a:tbl>
+              <a:tblPr/>
+              <a:tblGrid>
+                <a:gridCol w="1625009">
+                  <a:extLst>
+                    <a:ext uri="{9D8B030D-6E8A-4147-A177-3AD203B41FA5}">
+                      <a16:colId xmlns:a16="http://schemas.microsoft.com/office/drawing/2014/main" val="4183013849"/>
+                    </a:ext>
+                  </a:extLst>
+                </a:gridCol>
+                <a:gridCol w="1625009">
+                  <a:extLst>
+                    <a:ext uri="{9D8B030D-6E8A-4147-A177-3AD203B41FA5}">
+                      <a16:colId xmlns:a16="http://schemas.microsoft.com/office/drawing/2014/main" val="406379503"/>
+                    </a:ext>
+                  </a:extLst>
+                </a:gridCol>
+                <a:gridCol w="1625009">
+                  <a:extLst>
+                    <a:ext uri="{9D8B030D-6E8A-4147-A177-3AD203B41FA5}">
+                      <a16:colId xmlns:a16="http://schemas.microsoft.com/office/drawing/2014/main" val="3581556549"/>
+                    </a:ext>
+                  </a:extLst>
+                </a:gridCol>
+              </a:tblGrid>
+              <a:tr h="249866">
+                <a:tc>
+                  <a:txBody>
+                    <a:bodyPr/>
+                    <a:lstStyle/>
+                    <a:p>
+                      <a:r>
+                        <a:rPr lang="en-GB" sz="1200"/>
+                        <a:t>Function</a:t>
+                      </a:r>
+                    </a:p>
+                  </a:txBody>
+                  <a:tcPr anchor="ctr">
+                    <a:lnL w="12700" cap="flat" cmpd="sng" algn="ctr">
+                      <a:solidFill>
+                        <a:schemeClr val="tx1"/>
+                      </a:solidFill>
+                      <a:prstDash val="solid"/>
+                      <a:round/>
+                      <a:headEnd type="none" w="med" len="med"/>
+                      <a:tailEnd type="none" w="med" len="med"/>
+                    </a:lnL>
+                    <a:lnR w="12700" cap="flat" cmpd="sng" algn="ctr">
+                      <a:solidFill>
+                        <a:schemeClr val="tx1"/>
+                      </a:solidFill>
+                      <a:prstDash val="solid"/>
+                      <a:round/>
+                      <a:headEnd type="none" w="med" len="med"/>
+                      <a:tailEnd type="none" w="med" len="med"/>
+                    </a:lnR>
+                    <a:lnT w="12700" cap="flat" cmpd="sng" algn="ctr">
+                      <a:solidFill>
+                        <a:schemeClr val="tx1"/>
+                      </a:solidFill>
+                      <a:prstDash val="solid"/>
+                      <a:round/>
+                      <a:headEnd type="none" w="med" len="med"/>
+                      <a:tailEnd type="none" w="med" len="med"/>
+                    </a:lnT>
+                    <a:lnB w="12700" cap="flat" cmpd="sng" algn="ctr">
+                      <a:solidFill>
+                        <a:schemeClr val="tx1"/>
+                      </a:solidFill>
+                      <a:prstDash val="solid"/>
+                      <a:round/>
+                      <a:headEnd type="none" w="med" len="med"/>
+                      <a:tailEnd type="none" w="med" len="med"/>
+                    </a:lnB>
+                  </a:tcPr>
+                </a:tc>
+                <a:tc>
+                  <a:txBody>
+                    <a:bodyPr/>
+                    <a:lstStyle/>
+                    <a:p>
+                      <a:r>
+                        <a:rPr lang="en-GB" sz="1200"/>
+                        <a:t>Problem</a:t>
+                      </a:r>
+                    </a:p>
+                  </a:txBody>
+                  <a:tcPr anchor="ctr">
+                    <a:lnL w="12700" cap="flat" cmpd="sng" algn="ctr">
+                      <a:solidFill>
+                        <a:schemeClr val="tx1"/>
+                      </a:solidFill>
+                      <a:prstDash val="solid"/>
+                      <a:round/>
+                      <a:headEnd type="none" w="med" len="med"/>
+                      <a:tailEnd type="none" w="med" len="med"/>
+                    </a:lnL>
+                    <a:lnR w="12700" cap="flat" cmpd="sng" algn="ctr">
+                      <a:solidFill>
+                        <a:schemeClr val="tx1"/>
+                      </a:solidFill>
+                      <a:prstDash val="solid"/>
+                      <a:round/>
+                      <a:headEnd type="none" w="med" len="med"/>
+                      <a:tailEnd type="none" w="med" len="med"/>
+                    </a:lnR>
+                    <a:lnT w="12700" cap="flat" cmpd="sng" algn="ctr">
+                      <a:solidFill>
+                        <a:schemeClr val="tx1"/>
+                      </a:solidFill>
+                      <a:prstDash val="solid"/>
+                      <a:round/>
+                      <a:headEnd type="none" w="med" len="med"/>
+                      <a:tailEnd type="none" w="med" len="med"/>
+                    </a:lnT>
+                    <a:lnB w="12700" cap="flat" cmpd="sng" algn="ctr">
+                      <a:solidFill>
+                        <a:schemeClr val="tx1"/>
+                      </a:solidFill>
+                      <a:prstDash val="solid"/>
+                      <a:round/>
+                      <a:headEnd type="none" w="med" len="med"/>
+                      <a:tailEnd type="none" w="med" len="med"/>
+                    </a:lnB>
+                  </a:tcPr>
+                </a:tc>
+                <a:tc>
+                  <a:txBody>
+                    <a:bodyPr/>
+                    <a:lstStyle/>
+                    <a:p>
+                      <a:r>
+                        <a:rPr lang="en-GB" sz="1200"/>
+                        <a:t>What's happening</a:t>
+                      </a:r>
+                    </a:p>
+                  </a:txBody>
+                  <a:tcPr anchor="ctr">
+                    <a:lnL w="12700" cap="flat" cmpd="sng" algn="ctr">
+                      <a:solidFill>
+                        <a:schemeClr val="tx1"/>
+                      </a:solidFill>
+                      <a:prstDash val="solid"/>
+                      <a:round/>
+                      <a:headEnd type="none" w="med" len="med"/>
+                      <a:tailEnd type="none" w="med" len="med"/>
+                    </a:lnL>
+                    <a:lnR w="12700" cap="flat" cmpd="sng" algn="ctr">
+                      <a:solidFill>
+                        <a:schemeClr val="tx1"/>
+                      </a:solidFill>
+                      <a:prstDash val="solid"/>
+                      <a:round/>
+                      <a:headEnd type="none" w="med" len="med"/>
+                      <a:tailEnd type="none" w="med" len="med"/>
+                    </a:lnR>
+                    <a:lnT w="12700" cap="flat" cmpd="sng" algn="ctr">
+                      <a:solidFill>
+                        <a:schemeClr val="tx1"/>
+                      </a:solidFill>
+                      <a:prstDash val="solid"/>
+                      <a:round/>
+                      <a:headEnd type="none" w="med" len="med"/>
+                      <a:tailEnd type="none" w="med" len="med"/>
+                    </a:lnT>
+                    <a:lnB w="12700" cap="flat" cmpd="sng" algn="ctr">
+                      <a:solidFill>
+                        <a:schemeClr val="tx1"/>
+                      </a:solidFill>
+                      <a:prstDash val="solid"/>
+                      <a:round/>
+                      <a:headEnd type="none" w="med" len="med"/>
+                      <a:tailEnd type="none" w="med" len="med"/>
+                    </a:lnB>
+                  </a:tcPr>
+                </a:tc>
+                <a:extLst>
+                  <a:ext uri="{0D108BD9-81ED-4DB2-BD59-A6C34878D82A}">
+                    <a16:rowId xmlns:a16="http://schemas.microsoft.com/office/drawing/2014/main" val="1860644810"/>
+                  </a:ext>
+                </a:extLst>
+              </a:tr>
+              <a:tr h="437265">
+                <a:tc>
+                  <a:txBody>
+                    <a:bodyPr/>
+                    <a:lstStyle/>
+                    <a:p>
+                      <a:r>
+                        <a:rPr lang="en-GB" sz="1200"/>
+                        <a:t>F5, F7, F8</a:t>
+                      </a:r>
+                    </a:p>
+                  </a:txBody>
+                  <a:tcPr anchor="ctr">
+                    <a:lnL w="12700" cap="flat" cmpd="sng" algn="ctr">
+                      <a:solidFill>
+                        <a:schemeClr val="tx1"/>
+                      </a:solidFill>
+                      <a:prstDash val="solid"/>
+                      <a:round/>
+                      <a:headEnd type="none" w="med" len="med"/>
+                      <a:tailEnd type="none" w="med" len="med"/>
+                    </a:lnL>
+                    <a:lnR w="12700" cap="flat" cmpd="sng" algn="ctr">
+                      <a:solidFill>
+                        <a:schemeClr val="tx1"/>
+                      </a:solidFill>
+                      <a:prstDash val="solid"/>
+                      <a:round/>
+                      <a:headEnd type="none" w="med" len="med"/>
+                      <a:tailEnd type="none" w="med" len="med"/>
+                    </a:lnR>
+                    <a:lnT w="12700" cap="flat" cmpd="sng" algn="ctr">
+                      <a:solidFill>
+                        <a:schemeClr val="tx1"/>
+                      </a:solidFill>
+                      <a:prstDash val="solid"/>
+                      <a:round/>
+                      <a:headEnd type="none" w="med" len="med"/>
+                      <a:tailEnd type="none" w="med" len="med"/>
+                    </a:lnT>
+                    <a:lnB w="12700" cap="flat" cmpd="sng" algn="ctr">
+                      <a:solidFill>
+                        <a:schemeClr val="tx1"/>
+                      </a:solidFill>
+                      <a:prstDash val="solid"/>
+                      <a:round/>
+                      <a:headEnd type="none" w="med" len="med"/>
+                      <a:tailEnd type="none" w="med" len="med"/>
+                    </a:lnB>
+                  </a:tcPr>
+                </a:tc>
+                <a:tc>
+                  <a:txBody>
+                    <a:bodyPr/>
+                    <a:lstStyle/>
+                    <a:p>
+                      <a:r>
+                        <a:rPr lang="en-GB" sz="1200" dirty="0" err="1"/>
+                        <a:t>Rastrigin</a:t>
+                      </a:r>
+                      <a:r>
+                        <a:rPr lang="en-GB" sz="1200" dirty="0"/>
+                        <a:t> variants</a:t>
+                      </a:r>
+                    </a:p>
+                  </a:txBody>
+                  <a:tcPr anchor="ctr">
+                    <a:lnL w="12700" cap="flat" cmpd="sng" algn="ctr">
+                      <a:solidFill>
+                        <a:schemeClr val="tx1"/>
+                      </a:solidFill>
+                      <a:prstDash val="solid"/>
+                      <a:round/>
+                      <a:headEnd type="none" w="med" len="med"/>
+                      <a:tailEnd type="none" w="med" len="med"/>
+                    </a:lnL>
+                    <a:lnR w="12700" cap="flat" cmpd="sng" algn="ctr">
+                      <a:solidFill>
+                        <a:schemeClr val="tx1"/>
+                      </a:solidFill>
+                      <a:prstDash val="solid"/>
+                      <a:round/>
+                      <a:headEnd type="none" w="med" len="med"/>
+                      <a:tailEnd type="none" w="med" len="med"/>
+                    </a:lnR>
+                    <a:lnT w="12700" cap="flat" cmpd="sng" algn="ctr">
+                      <a:solidFill>
+                        <a:schemeClr val="tx1"/>
+                      </a:solidFill>
+                      <a:prstDash val="solid"/>
+                      <a:round/>
+                      <a:headEnd type="none" w="med" len="med"/>
+                      <a:tailEnd type="none" w="med" len="med"/>
+                    </a:lnT>
+                    <a:lnB w="12700" cap="flat" cmpd="sng" algn="ctr">
+                      <a:solidFill>
+                        <a:schemeClr val="tx1"/>
+                      </a:solidFill>
+                      <a:prstDash val="solid"/>
+                      <a:round/>
+                      <a:headEnd type="none" w="med" len="med"/>
+                      <a:tailEnd type="none" w="med" len="med"/>
+                    </a:lnB>
+                  </a:tcPr>
+                </a:tc>
+                <a:tc>
+                  <a:txBody>
+                    <a:bodyPr/>
+                    <a:lstStyle/>
+                    <a:p>
+                      <a:r>
+                        <a:rPr lang="en-GB" sz="1200" dirty="0"/>
+                        <a:t>Multimodal because elite archive may be locking onto local optima too early</a:t>
+                      </a:r>
+                    </a:p>
+                  </a:txBody>
+                  <a:tcPr anchor="ctr">
+                    <a:lnL w="12700" cap="flat" cmpd="sng" algn="ctr">
+                      <a:solidFill>
+                        <a:schemeClr val="tx1"/>
+                      </a:solidFill>
+                      <a:prstDash val="solid"/>
+                      <a:round/>
+                      <a:headEnd type="none" w="med" len="med"/>
+                      <a:tailEnd type="none" w="med" len="med"/>
+                    </a:lnL>
+                    <a:lnR w="12700" cap="flat" cmpd="sng" algn="ctr">
+                      <a:solidFill>
+                        <a:schemeClr val="tx1"/>
+                      </a:solidFill>
+                      <a:prstDash val="solid"/>
+                      <a:round/>
+                      <a:headEnd type="none" w="med" len="med"/>
+                      <a:tailEnd type="none" w="med" len="med"/>
+                    </a:lnR>
+                    <a:lnT w="12700" cap="flat" cmpd="sng" algn="ctr">
+                      <a:solidFill>
+                        <a:schemeClr val="tx1"/>
+                      </a:solidFill>
+                      <a:prstDash val="solid"/>
+                      <a:round/>
+                      <a:headEnd type="none" w="med" len="med"/>
+                      <a:tailEnd type="none" w="med" len="med"/>
+                    </a:lnT>
+                    <a:lnB w="12700" cap="flat" cmpd="sng" algn="ctr">
+                      <a:solidFill>
+                        <a:schemeClr val="tx1"/>
+                      </a:solidFill>
+                      <a:prstDash val="solid"/>
+                      <a:round/>
+                      <a:headEnd type="none" w="med" len="med"/>
+                      <a:tailEnd type="none" w="med" len="med"/>
+                    </a:lnB>
+                  </a:tcPr>
+                </a:tc>
+                <a:extLst>
+                  <a:ext uri="{0D108BD9-81ED-4DB2-BD59-A6C34878D82A}">
+                    <a16:rowId xmlns:a16="http://schemas.microsoft.com/office/drawing/2014/main" val="1831491544"/>
+                  </a:ext>
+                </a:extLst>
+              </a:tr>
+              <a:tr h="437265">
+                <a:tc>
+                  <a:txBody>
+                    <a:bodyPr/>
+                    <a:lstStyle/>
+                    <a:p>
+                      <a:r>
+                        <a:rPr lang="en-GB" sz="1200"/>
+                        <a:t>F10</a:t>
+                      </a:r>
+                    </a:p>
+                  </a:txBody>
+                  <a:tcPr anchor="ctr">
+                    <a:lnL w="12700" cap="flat" cmpd="sng" algn="ctr">
+                      <a:solidFill>
+                        <a:schemeClr val="tx1"/>
+                      </a:solidFill>
+                      <a:prstDash val="solid"/>
+                      <a:round/>
+                      <a:headEnd type="none" w="med" len="med"/>
+                      <a:tailEnd type="none" w="med" len="med"/>
+                    </a:lnL>
+                    <a:lnR w="12700" cap="flat" cmpd="sng" algn="ctr">
+                      <a:solidFill>
+                        <a:schemeClr val="tx1"/>
+                      </a:solidFill>
+                      <a:prstDash val="solid"/>
+                      <a:round/>
+                      <a:headEnd type="none" w="med" len="med"/>
+                      <a:tailEnd type="none" w="med" len="med"/>
+                    </a:lnR>
+                    <a:lnT w="12700" cap="flat" cmpd="sng" algn="ctr">
+                      <a:solidFill>
+                        <a:schemeClr val="tx1"/>
+                      </a:solidFill>
+                      <a:prstDash val="solid"/>
+                      <a:round/>
+                      <a:headEnd type="none" w="med" len="med"/>
+                      <a:tailEnd type="none" w="med" len="med"/>
+                    </a:lnT>
+                    <a:lnB w="12700" cap="flat" cmpd="sng" algn="ctr">
+                      <a:solidFill>
+                        <a:schemeClr val="tx1"/>
+                      </a:solidFill>
+                      <a:prstDash val="solid"/>
+                      <a:round/>
+                      <a:headEnd type="none" w="med" len="med"/>
+                      <a:tailEnd type="none" w="med" len="med"/>
+                    </a:lnB>
+                  </a:tcPr>
+                </a:tc>
+                <a:tc>
+                  <a:txBody>
+                    <a:bodyPr/>
+                    <a:lstStyle/>
+                    <a:p>
+                      <a:r>
+                        <a:rPr lang="en-GB" sz="1200"/>
+                        <a:t>Schwefel</a:t>
+                      </a:r>
+                    </a:p>
+                  </a:txBody>
+                  <a:tcPr anchor="ctr">
+                    <a:lnL w="12700" cap="flat" cmpd="sng" algn="ctr">
+                      <a:solidFill>
+                        <a:schemeClr val="tx1"/>
+                      </a:solidFill>
+                      <a:prstDash val="solid"/>
+                      <a:round/>
+                      <a:headEnd type="none" w="med" len="med"/>
+                      <a:tailEnd type="none" w="med" len="med"/>
+                    </a:lnL>
+                    <a:lnR w="12700" cap="flat" cmpd="sng" algn="ctr">
+                      <a:solidFill>
+                        <a:schemeClr val="tx1"/>
+                      </a:solidFill>
+                      <a:prstDash val="solid"/>
+                      <a:round/>
+                      <a:headEnd type="none" w="med" len="med"/>
+                      <a:tailEnd type="none" w="med" len="med"/>
+                    </a:lnR>
+                    <a:lnT w="12700" cap="flat" cmpd="sng" algn="ctr">
+                      <a:solidFill>
+                        <a:schemeClr val="tx1"/>
+                      </a:solidFill>
+                      <a:prstDash val="solid"/>
+                      <a:round/>
+                      <a:headEnd type="none" w="med" len="med"/>
+                      <a:tailEnd type="none" w="med" len="med"/>
+                    </a:lnT>
+                    <a:lnB w="12700" cap="flat" cmpd="sng" algn="ctr">
+                      <a:solidFill>
+                        <a:schemeClr val="tx1"/>
+                      </a:solidFill>
+                      <a:prstDash val="solid"/>
+                      <a:round/>
+                      <a:headEnd type="none" w="med" len="med"/>
+                      <a:tailEnd type="none" w="med" len="med"/>
+                    </a:lnB>
+                  </a:tcPr>
+                </a:tc>
+                <a:tc>
+                  <a:txBody>
+                    <a:bodyPr/>
+                    <a:lstStyle/>
+                    <a:p>
+                      <a:r>
+                        <a:rPr lang="en-GB" sz="1200" dirty="0"/>
+                        <a:t>Very deceptive as Modified 22% worse</a:t>
+                      </a:r>
+                    </a:p>
+                  </a:txBody>
+                  <a:tcPr anchor="ctr">
+                    <a:lnL w="12700" cap="flat" cmpd="sng" algn="ctr">
+                      <a:solidFill>
+                        <a:schemeClr val="tx1"/>
+                      </a:solidFill>
+                      <a:prstDash val="solid"/>
+                      <a:round/>
+                      <a:headEnd type="none" w="med" len="med"/>
+                      <a:tailEnd type="none" w="med" len="med"/>
+                    </a:lnL>
+                    <a:lnR w="12700" cap="flat" cmpd="sng" algn="ctr">
+                      <a:solidFill>
+                        <a:schemeClr val="tx1"/>
+                      </a:solidFill>
+                      <a:prstDash val="solid"/>
+                      <a:round/>
+                      <a:headEnd type="none" w="med" len="med"/>
+                      <a:tailEnd type="none" w="med" len="med"/>
+                    </a:lnR>
+                    <a:lnT w="12700" cap="flat" cmpd="sng" algn="ctr">
+                      <a:solidFill>
+                        <a:schemeClr val="tx1"/>
+                      </a:solidFill>
+                      <a:prstDash val="solid"/>
+                      <a:round/>
+                      <a:headEnd type="none" w="med" len="med"/>
+                      <a:tailEnd type="none" w="med" len="med"/>
+                    </a:lnT>
+                    <a:lnB w="12700" cap="flat" cmpd="sng" algn="ctr">
+                      <a:solidFill>
+                        <a:schemeClr val="tx1"/>
+                      </a:solidFill>
+                      <a:prstDash val="solid"/>
+                      <a:round/>
+                      <a:headEnd type="none" w="med" len="med"/>
+                      <a:tailEnd type="none" w="med" len="med"/>
+                    </a:lnB>
+                  </a:tcPr>
+                </a:tc>
+                <a:extLst>
+                  <a:ext uri="{0D108BD9-81ED-4DB2-BD59-A6C34878D82A}">
+                    <a16:rowId xmlns:a16="http://schemas.microsoft.com/office/drawing/2014/main" val="3551621561"/>
+                  </a:ext>
+                </a:extLst>
+              </a:tr>
+              <a:tr h="437265">
+                <a:tc>
+                  <a:txBody>
+                    <a:bodyPr/>
+                    <a:lstStyle/>
+                    <a:p>
+                      <a:r>
+                        <a:rPr lang="en-GB" sz="1200"/>
+                        <a:t>F15</a:t>
+                      </a:r>
+                    </a:p>
+                  </a:txBody>
+                  <a:tcPr anchor="ctr">
+                    <a:lnL w="12700" cap="flat" cmpd="sng" algn="ctr">
+                      <a:solidFill>
+                        <a:schemeClr val="tx1"/>
+                      </a:solidFill>
+                      <a:prstDash val="solid"/>
+                      <a:round/>
+                      <a:headEnd type="none" w="med" len="med"/>
+                      <a:tailEnd type="none" w="med" len="med"/>
+                    </a:lnL>
+                    <a:lnR w="12700" cap="flat" cmpd="sng" algn="ctr">
+                      <a:solidFill>
+                        <a:schemeClr val="tx1"/>
+                      </a:solidFill>
+                      <a:prstDash val="solid"/>
+                      <a:round/>
+                      <a:headEnd type="none" w="med" len="med"/>
+                      <a:tailEnd type="none" w="med" len="med"/>
+                    </a:lnR>
+                    <a:lnT w="12700" cap="flat" cmpd="sng" algn="ctr">
+                      <a:solidFill>
+                        <a:schemeClr val="tx1"/>
+                      </a:solidFill>
+                      <a:prstDash val="solid"/>
+                      <a:round/>
+                      <a:headEnd type="none" w="med" len="med"/>
+                      <a:tailEnd type="none" w="med" len="med"/>
+                    </a:lnT>
+                    <a:lnB w="12700" cap="flat" cmpd="sng" algn="ctr">
+                      <a:solidFill>
+                        <a:schemeClr val="tx1"/>
+                      </a:solidFill>
+                      <a:prstDash val="solid"/>
+                      <a:round/>
+                      <a:headEnd type="none" w="med" len="med"/>
+                      <a:tailEnd type="none" w="med" len="med"/>
+                    </a:lnB>
+                  </a:tcPr>
+                </a:tc>
+                <a:tc>
+                  <a:txBody>
+                    <a:bodyPr/>
+                    <a:lstStyle/>
+                    <a:p>
+                      <a:r>
+                        <a:rPr lang="en-GB" sz="1200"/>
+                        <a:t>Hybrid 5</a:t>
+                      </a:r>
+                    </a:p>
+                  </a:txBody>
+                  <a:tcPr anchor="ctr">
+                    <a:lnL w="12700" cap="flat" cmpd="sng" algn="ctr">
+                      <a:solidFill>
+                        <a:schemeClr val="tx1"/>
+                      </a:solidFill>
+                      <a:prstDash val="solid"/>
+                      <a:round/>
+                      <a:headEnd type="none" w="med" len="med"/>
+                      <a:tailEnd type="none" w="med" len="med"/>
+                    </a:lnL>
+                    <a:lnR w="12700" cap="flat" cmpd="sng" algn="ctr">
+                      <a:solidFill>
+                        <a:schemeClr val="tx1"/>
+                      </a:solidFill>
+                      <a:prstDash val="solid"/>
+                      <a:round/>
+                      <a:headEnd type="none" w="med" len="med"/>
+                      <a:tailEnd type="none" w="med" len="med"/>
+                    </a:lnR>
+                    <a:lnT w="12700" cap="flat" cmpd="sng" algn="ctr">
+                      <a:solidFill>
+                        <a:schemeClr val="tx1"/>
+                      </a:solidFill>
+                      <a:prstDash val="solid"/>
+                      <a:round/>
+                      <a:headEnd type="none" w="med" len="med"/>
+                      <a:tailEnd type="none" w="med" len="med"/>
+                    </a:lnT>
+                    <a:lnB w="12700" cap="flat" cmpd="sng" algn="ctr">
+                      <a:solidFill>
+                        <a:schemeClr val="tx1"/>
+                      </a:solidFill>
+                      <a:prstDash val="solid"/>
+                      <a:round/>
+                      <a:headEnd type="none" w="med" len="med"/>
+                      <a:tailEnd type="none" w="med" len="med"/>
+                    </a:lnB>
+                  </a:tcPr>
+                </a:tc>
+                <a:tc>
+                  <a:txBody>
+                    <a:bodyPr/>
+                    <a:lstStyle/>
+                    <a:p>
+                      <a:r>
+                        <a:rPr lang="en-GB" sz="1200" dirty="0"/>
+                        <a:t>Biggest loss as the Modified 45% worse, high std too</a:t>
+                      </a:r>
+                    </a:p>
+                  </a:txBody>
+                  <a:tcPr anchor="ctr">
+                    <a:lnL w="12700" cap="flat" cmpd="sng" algn="ctr">
+                      <a:solidFill>
+                        <a:schemeClr val="tx1"/>
+                      </a:solidFill>
+                      <a:prstDash val="solid"/>
+                      <a:round/>
+                      <a:headEnd type="none" w="med" len="med"/>
+                      <a:tailEnd type="none" w="med" len="med"/>
+                    </a:lnL>
+                    <a:lnR w="12700" cap="flat" cmpd="sng" algn="ctr">
+                      <a:solidFill>
+                        <a:schemeClr val="tx1"/>
+                      </a:solidFill>
+                      <a:prstDash val="solid"/>
+                      <a:round/>
+                      <a:headEnd type="none" w="med" len="med"/>
+                      <a:tailEnd type="none" w="med" len="med"/>
+                    </a:lnR>
+                    <a:lnT w="12700" cap="flat" cmpd="sng" algn="ctr">
+                      <a:solidFill>
+                        <a:schemeClr val="tx1"/>
+                      </a:solidFill>
+                      <a:prstDash val="solid"/>
+                      <a:round/>
+                      <a:headEnd type="none" w="med" len="med"/>
+                      <a:tailEnd type="none" w="med" len="med"/>
+                    </a:lnT>
+                    <a:lnB w="12700" cap="flat" cmpd="sng" algn="ctr">
+                      <a:solidFill>
+                        <a:schemeClr val="tx1"/>
+                      </a:solidFill>
+                      <a:prstDash val="solid"/>
+                      <a:round/>
+                      <a:headEnd type="none" w="med" len="med"/>
+                      <a:tailEnd type="none" w="med" len="med"/>
+                    </a:lnB>
+                  </a:tcPr>
+                </a:tc>
+                <a:extLst>
+                  <a:ext uri="{0D108BD9-81ED-4DB2-BD59-A6C34878D82A}">
+                    <a16:rowId xmlns:a16="http://schemas.microsoft.com/office/drawing/2014/main" val="2321228054"/>
+                  </a:ext>
+                </a:extLst>
+              </a:tr>
+              <a:tr h="249866">
+                <a:tc>
+                  <a:txBody>
+                    <a:bodyPr/>
+                    <a:lstStyle/>
+                    <a:p>
+                      <a:r>
+                        <a:rPr lang="en-GB" sz="1200"/>
+                        <a:t>F14, F18, F21, F24</a:t>
+                      </a:r>
+                    </a:p>
+                  </a:txBody>
+                  <a:tcPr anchor="ctr">
+                    <a:lnL w="12700" cap="flat" cmpd="sng" algn="ctr">
+                      <a:solidFill>
+                        <a:schemeClr val="tx1"/>
+                      </a:solidFill>
+                      <a:prstDash val="solid"/>
+                      <a:round/>
+                      <a:headEnd type="none" w="med" len="med"/>
+                      <a:tailEnd type="none" w="med" len="med"/>
+                    </a:lnL>
+                    <a:lnR w="12700" cap="flat" cmpd="sng" algn="ctr">
+                      <a:solidFill>
+                        <a:schemeClr val="tx1"/>
+                      </a:solidFill>
+                      <a:prstDash val="solid"/>
+                      <a:round/>
+                      <a:headEnd type="none" w="med" len="med"/>
+                      <a:tailEnd type="none" w="med" len="med"/>
+                    </a:lnR>
+                    <a:lnT w="12700" cap="flat" cmpd="sng" algn="ctr">
+                      <a:solidFill>
+                        <a:schemeClr val="tx1"/>
+                      </a:solidFill>
+                      <a:prstDash val="solid"/>
+                      <a:round/>
+                      <a:headEnd type="none" w="med" len="med"/>
+                      <a:tailEnd type="none" w="med" len="med"/>
+                    </a:lnT>
+                    <a:lnB w="12700" cap="flat" cmpd="sng" algn="ctr">
+                      <a:solidFill>
+                        <a:schemeClr val="tx1"/>
+                      </a:solidFill>
+                      <a:prstDash val="solid"/>
+                      <a:round/>
+                      <a:headEnd type="none" w="med" len="med"/>
+                      <a:tailEnd type="none" w="med" len="med"/>
+                    </a:lnB>
+                  </a:tcPr>
+                </a:tc>
+                <a:tc>
+                  <a:txBody>
+                    <a:bodyPr/>
+                    <a:lstStyle/>
+                    <a:p>
+                      <a:r>
+                        <a:rPr lang="en-GB" sz="1200"/>
+                        <a:t>Hybrid/Composition</a:t>
+                      </a:r>
+                    </a:p>
+                  </a:txBody>
+                  <a:tcPr anchor="ctr">
+                    <a:lnL w="12700" cap="flat" cmpd="sng" algn="ctr">
+                      <a:solidFill>
+                        <a:schemeClr val="tx1"/>
+                      </a:solidFill>
+                      <a:prstDash val="solid"/>
+                      <a:round/>
+                      <a:headEnd type="none" w="med" len="med"/>
+                      <a:tailEnd type="none" w="med" len="med"/>
+                    </a:lnL>
+                    <a:lnR w="12700" cap="flat" cmpd="sng" algn="ctr">
+                      <a:solidFill>
+                        <a:schemeClr val="tx1"/>
+                      </a:solidFill>
+                      <a:prstDash val="solid"/>
+                      <a:round/>
+                      <a:headEnd type="none" w="med" len="med"/>
+                      <a:tailEnd type="none" w="med" len="med"/>
+                    </a:lnR>
+                    <a:lnT w="12700" cap="flat" cmpd="sng" algn="ctr">
+                      <a:solidFill>
+                        <a:schemeClr val="tx1"/>
+                      </a:solidFill>
+                      <a:prstDash val="solid"/>
+                      <a:round/>
+                      <a:headEnd type="none" w="med" len="med"/>
+                      <a:tailEnd type="none" w="med" len="med"/>
+                    </a:lnT>
+                    <a:lnB w="12700" cap="flat" cmpd="sng" algn="ctr">
+                      <a:solidFill>
+                        <a:schemeClr val="tx1"/>
+                      </a:solidFill>
+                      <a:prstDash val="solid"/>
+                      <a:round/>
+                      <a:headEnd type="none" w="med" len="med"/>
+                      <a:tailEnd type="none" w="med" len="med"/>
+                    </a:lnB>
+                  </a:tcPr>
+                </a:tc>
+                <a:tc>
+                  <a:txBody>
+                    <a:bodyPr/>
+                    <a:lstStyle/>
+                    <a:p>
+                      <a:r>
+                        <a:rPr lang="en-GB" sz="1200" dirty="0"/>
+                        <a:t>Marginal losses</a:t>
+                      </a:r>
+                    </a:p>
+                  </a:txBody>
+                  <a:tcPr anchor="ctr">
+                    <a:lnL w="12700" cap="flat" cmpd="sng" algn="ctr">
+                      <a:solidFill>
+                        <a:schemeClr val="tx1"/>
+                      </a:solidFill>
+                      <a:prstDash val="solid"/>
+                      <a:round/>
+                      <a:headEnd type="none" w="med" len="med"/>
+                      <a:tailEnd type="none" w="med" len="med"/>
+                    </a:lnL>
+                    <a:lnR w="12700" cap="flat" cmpd="sng" algn="ctr">
+                      <a:solidFill>
+                        <a:schemeClr val="tx1"/>
+                      </a:solidFill>
+                      <a:prstDash val="solid"/>
+                      <a:round/>
+                      <a:headEnd type="none" w="med" len="med"/>
+                      <a:tailEnd type="none" w="med" len="med"/>
+                    </a:lnR>
+                    <a:lnT w="12700" cap="flat" cmpd="sng" algn="ctr">
+                      <a:solidFill>
+                        <a:schemeClr val="tx1"/>
+                      </a:solidFill>
+                      <a:prstDash val="solid"/>
+                      <a:round/>
+                      <a:headEnd type="none" w="med" len="med"/>
+                      <a:tailEnd type="none" w="med" len="med"/>
+                    </a:lnT>
+                    <a:lnB w="12700" cap="flat" cmpd="sng" algn="ctr">
+                      <a:solidFill>
+                        <a:schemeClr val="tx1"/>
+                      </a:solidFill>
+                      <a:prstDash val="solid"/>
+                      <a:round/>
+                      <a:headEnd type="none" w="med" len="med"/>
+                      <a:tailEnd type="none" w="med" len="med"/>
+                    </a:lnB>
+                  </a:tcPr>
+                </a:tc>
+                <a:extLst>
+                  <a:ext uri="{0D108BD9-81ED-4DB2-BD59-A6C34878D82A}">
+                    <a16:rowId xmlns:a16="http://schemas.microsoft.com/office/drawing/2014/main" val="1536893463"/>
+                  </a:ext>
+                </a:extLst>
+              </a:tr>
+            </a:tbl>
+          </a:graphicData>
+        </a:graphic>
+      </p:graphicFrame>
+      <p:sp>
+        <p:nvSpPr>
+          <p:cNvPr id="52" name="Rectangle 1">
+            <a:extLst>
+              <a:ext uri="{FF2B5EF4-FFF2-40B4-BE49-F238E27FC236}">
+                <a16:creationId xmlns:a16="http://schemas.microsoft.com/office/drawing/2014/main" id="{2C378A5F-1FF9-E96B-03F3-EB259B5EECCB}"/>
+              </a:ext>
+            </a:extLst>
+          </p:cNvPr>
+          <p:cNvSpPr>
+            <a:spLocks noChangeArrowheads="1"/>
+          </p:cNvSpPr>
+          <p:nvPr/>
+        </p:nvSpPr>
+        <p:spPr bwMode="auto">
+          <a:xfrm>
+            <a:off x="531371" y="1120676"/>
+            <a:ext cx="6259290" cy="2308324"/>
+          </a:xfrm>
+          <a:prstGeom prst="rect">
+            <a:avLst/>
+          </a:prstGeom>
+          <a:noFill/>
+          <a:ln>
+            <a:noFill/>
+          </a:ln>
+          <a:effectLst/>
+          <a:extLst>
+            <a:ext uri="{909E8E84-426E-40DD-AFC4-6F175D3DCCD1}">
+              <a14:hiddenFill xmlns:a14="http://schemas.microsoft.com/office/drawing/2010/main">
+                <a:solidFill>
+                  <a:schemeClr val="accent1"/>
+                </a:solidFill>
+              </a14:hiddenFill>
+            </a:ext>
+            <a:ext uri="{91240B29-F687-4F45-9708-019B960494DF}">
+              <a14:hiddenLine xmlns:a14="http://schemas.microsoft.com/office/drawing/2010/main" w="9525">
+                <a:solidFill>
+                  <a:schemeClr val="tx1"/>
+                </a:solidFill>
+                <a:miter lim="800000"/>
+                <a:headEnd/>
+                <a:tailEnd/>
+              </a14:hiddenLine>
+            </a:ext>
+            <a:ext uri="{AF507438-7753-43E0-B8FC-AC1667EBCBE1}">
+              <a14:hiddenEffects xmlns:a14="http://schemas.microsoft.com/office/drawing/2010/main">
+                <a:effectLst>
+                  <a:outerShdw dist="35921" dir="2700000" algn="ctr" rotWithShape="0">
+                    <a:schemeClr val="bg2"/>
+                  </a:outerShdw>
+                </a:effectLst>
+              </a14:hiddenEffects>
+            </a:ext>
+          </a:extLst>
+        </p:spPr>
+        <p:txBody>
+          <a:bodyPr vert="horz" wrap="square" lIns="91440" tIns="45720" rIns="91440" bIns="45720" numCol="1" anchor="ctr" anchorCtr="0" compatLnSpc="1">
+            <a:prstTxWarp prst="textNoShape">
+              <a:avLst/>
+            </a:prstTxWarp>
+            <a:spAutoFit/>
+          </a:bodyPr>
+          <a:lstStyle>
+            <a:lvl1pPr eaLnBrk="0" fontAlgn="base" hangingPunct="0">
+              <a:spcBef>
+                <a:spcPct val="0"/>
+              </a:spcBef>
+              <a:spcAft>
+                <a:spcPct val="0"/>
+              </a:spcAft>
+              <a:defRPr>
+                <a:solidFill>
+                  <a:schemeClr val="tx1"/>
+                </a:solidFill>
+                <a:latin typeface="Arial" panose="020B0604020202020204" pitchFamily="34" charset="0"/>
+              </a:defRPr>
+            </a:lvl1pPr>
+            <a:lvl2pPr eaLnBrk="0" fontAlgn="base" hangingPunct="0">
+              <a:spcBef>
+                <a:spcPct val="0"/>
+              </a:spcBef>
+              <a:spcAft>
+                <a:spcPct val="0"/>
+              </a:spcAft>
+              <a:defRPr>
+                <a:solidFill>
+                  <a:schemeClr val="tx1"/>
+                </a:solidFill>
+                <a:latin typeface="Arial" panose="020B0604020202020204" pitchFamily="34" charset="0"/>
+              </a:defRPr>
+            </a:lvl2pPr>
+            <a:lvl3pPr eaLnBrk="0" fontAlgn="base" hangingPunct="0">
+              <a:spcBef>
+                <a:spcPct val="0"/>
+              </a:spcBef>
+              <a:spcAft>
+                <a:spcPct val="0"/>
+              </a:spcAft>
+              <a:defRPr>
+                <a:solidFill>
+                  <a:schemeClr val="tx1"/>
+                </a:solidFill>
+                <a:latin typeface="Arial" panose="020B0604020202020204" pitchFamily="34" charset="0"/>
+              </a:defRPr>
+            </a:lvl3pPr>
+            <a:lvl4pPr eaLnBrk="0" fontAlgn="base" hangingPunct="0">
+              <a:spcBef>
+                <a:spcPct val="0"/>
+              </a:spcBef>
+              <a:spcAft>
+                <a:spcPct val="0"/>
+              </a:spcAft>
+              <a:defRPr>
+                <a:solidFill>
+                  <a:schemeClr val="tx1"/>
+                </a:solidFill>
+                <a:latin typeface="Arial" panose="020B0604020202020204" pitchFamily="34" charset="0"/>
+              </a:defRPr>
+            </a:lvl4pPr>
+            <a:lvl5pPr eaLnBrk="0" fontAlgn="base" hangingPunct="0">
+              <a:spcBef>
+                <a:spcPct val="0"/>
+              </a:spcBef>
+              <a:spcAft>
+                <a:spcPct val="0"/>
+              </a:spcAft>
+              <a:defRPr>
+                <a:solidFill>
+                  <a:schemeClr val="tx1"/>
+                </a:solidFill>
+                <a:latin typeface="Arial" panose="020B0604020202020204" pitchFamily="34" charset="0"/>
+              </a:defRPr>
+            </a:lvl5pPr>
+            <a:lvl6pPr eaLnBrk="0" fontAlgn="base" hangingPunct="0">
+              <a:spcBef>
+                <a:spcPct val="0"/>
+              </a:spcBef>
+              <a:spcAft>
+                <a:spcPct val="0"/>
+              </a:spcAft>
+              <a:defRPr>
+                <a:solidFill>
+                  <a:schemeClr val="tx1"/>
+                </a:solidFill>
+                <a:latin typeface="Arial" panose="020B0604020202020204" pitchFamily="34" charset="0"/>
+              </a:defRPr>
+            </a:lvl6pPr>
+            <a:lvl7pPr eaLnBrk="0" fontAlgn="base" hangingPunct="0">
+              <a:spcBef>
+                <a:spcPct val="0"/>
+              </a:spcBef>
+              <a:spcAft>
+                <a:spcPct val="0"/>
+              </a:spcAft>
+              <a:defRPr>
+                <a:solidFill>
+                  <a:schemeClr val="tx1"/>
+                </a:solidFill>
+                <a:latin typeface="Arial" panose="020B0604020202020204" pitchFamily="34" charset="0"/>
+              </a:defRPr>
+            </a:lvl7pPr>
+            <a:lvl8pPr eaLnBrk="0" fontAlgn="base" hangingPunct="0">
+              <a:spcBef>
+                <a:spcPct val="0"/>
+              </a:spcBef>
+              <a:spcAft>
+                <a:spcPct val="0"/>
+              </a:spcAft>
+              <a:defRPr>
+                <a:solidFill>
+                  <a:schemeClr val="tx1"/>
+                </a:solidFill>
+                <a:latin typeface="Arial" panose="020B0604020202020204" pitchFamily="34" charset="0"/>
+              </a:defRPr>
+            </a:lvl8pPr>
+            <a:lvl9pPr eaLnBrk="0" fontAlgn="base" hangingPunct="0">
+              <a:spcBef>
+                <a:spcPct val="0"/>
+              </a:spcBef>
+              <a:spcAft>
+                <a:spcPct val="0"/>
+              </a:spcAft>
+              <a:defRPr>
+                <a:solidFill>
+                  <a:schemeClr val="tx1"/>
+                </a:solidFill>
+                <a:latin typeface="Arial" panose="020B0604020202020204" pitchFamily="34" charset="0"/>
+              </a:defRPr>
+            </a:lvl9pPr>
+          </a:lstStyle>
+          <a:p>
+            <a:pPr marL="0" marR="0" lvl="0" indent="0" algn="just" defTabSz="914400" rtl="0" eaLnBrk="0" fontAlgn="base" latinLnBrk="0" hangingPunct="0">
+              <a:lnSpc>
+                <a:spcPct val="100000"/>
+              </a:lnSpc>
+              <a:spcBef>
+                <a:spcPct val="0"/>
+              </a:spcBef>
+              <a:spcAft>
+                <a:spcPct val="0"/>
+              </a:spcAft>
+              <a:buClrTx/>
+              <a:buSzTx/>
+              <a:buFontTx/>
+              <a:buNone/>
+              <a:tabLst/>
+            </a:pPr>
+            <a:r>
+              <a:rPr kumimoji="0" lang="en-LK" altLang="en-LK" sz="1200" b="1" i="0" u="none" strike="noStrike" cap="none" normalizeH="0" baseline="0" dirty="0">
+                <a:ln>
+                  <a:noFill/>
+                </a:ln>
+                <a:effectLst/>
+                <a:latin typeface="+mn-lt"/>
+              </a:rPr>
+              <a:t>Modified PSO wins 20 out of 29 functions.</a:t>
+            </a:r>
+            <a:r>
+              <a:rPr kumimoji="0" lang="en-LK" altLang="en-LK" sz="1200" b="0" i="0" u="none" strike="noStrike" cap="none" normalizeH="0" baseline="0" dirty="0">
+                <a:ln>
+                  <a:noFill/>
+                </a:ln>
+                <a:effectLst/>
+                <a:latin typeface="+mn-lt"/>
+              </a:rPr>
+              <a:t> The standout is F2, where Modified PSO is roughly better than Standard. On most of the composition functions (F21–F29) and hybrid functions (F11–F20), the Modified PSO consistently produces lower mean fitness and crucially a much lower std (standard deviation), meaning it's more stable and repeatable.</a:t>
+            </a:r>
+          </a:p>
+          <a:p>
+            <a:pPr marL="0" marR="0" lvl="0" indent="0" algn="just" defTabSz="914400" rtl="0" eaLnBrk="0" fontAlgn="base" latinLnBrk="0" hangingPunct="0">
+              <a:lnSpc>
+                <a:spcPct val="100000"/>
+              </a:lnSpc>
+              <a:spcBef>
+                <a:spcPct val="0"/>
+              </a:spcBef>
+              <a:spcAft>
+                <a:spcPct val="0"/>
+              </a:spcAft>
+              <a:buClrTx/>
+              <a:buSzTx/>
+              <a:buFontTx/>
+              <a:buNone/>
+              <a:tabLst/>
+            </a:pPr>
+            <a:endParaRPr kumimoji="0" lang="en-LK" altLang="en-LK" sz="1200" b="0" i="0" u="none" strike="noStrike" cap="none" normalizeH="0" baseline="0" dirty="0">
+              <a:ln>
+                <a:noFill/>
+              </a:ln>
+              <a:effectLst/>
+              <a:latin typeface="+mn-lt"/>
+            </a:endParaRPr>
+          </a:p>
+          <a:p>
+            <a:pPr marL="0" marR="0" lvl="0" indent="0" algn="just" defTabSz="914400" rtl="0" eaLnBrk="0" fontAlgn="base" latinLnBrk="0" hangingPunct="0">
+              <a:lnSpc>
+                <a:spcPct val="100000"/>
+              </a:lnSpc>
+              <a:spcBef>
+                <a:spcPct val="0"/>
+              </a:spcBef>
+              <a:spcAft>
+                <a:spcPct val="0"/>
+              </a:spcAft>
+              <a:buClrTx/>
+              <a:buSzTx/>
+              <a:buFontTx/>
+              <a:buNone/>
+              <a:tabLst/>
+            </a:pPr>
+            <a:r>
+              <a:rPr kumimoji="0" lang="en-LK" altLang="en-LK" sz="1200" b="1" i="0" u="none" strike="noStrike" cap="none" normalizeH="0" baseline="0" dirty="0">
+                <a:ln>
+                  <a:noFill/>
+                </a:ln>
+                <a:effectLst/>
+                <a:latin typeface="+mn-lt"/>
+              </a:rPr>
+              <a:t>The concerning cases, 9 functions where Standard wins:</a:t>
+            </a:r>
+            <a:endParaRPr kumimoji="0" lang="en-LK" altLang="en-LK" sz="1200" b="0" i="0" u="none" strike="noStrike" cap="none" normalizeH="0" baseline="0" dirty="0">
+              <a:ln>
+                <a:noFill/>
+              </a:ln>
+              <a:effectLst/>
+              <a:latin typeface="+mn-lt"/>
+            </a:endParaRPr>
+          </a:p>
+          <a:p>
+            <a:pPr marL="0" marR="0" lvl="0" indent="0" algn="just" defTabSz="914400" rtl="0" eaLnBrk="0" fontAlgn="base" latinLnBrk="0" hangingPunct="0">
+              <a:lnSpc>
+                <a:spcPct val="100000"/>
+              </a:lnSpc>
+              <a:spcBef>
+                <a:spcPct val="0"/>
+              </a:spcBef>
+              <a:spcAft>
+                <a:spcPct val="0"/>
+              </a:spcAft>
+              <a:buClrTx/>
+              <a:buSzTx/>
+              <a:buFontTx/>
+              <a:buNone/>
+              <a:tabLst/>
+            </a:pPr>
+            <a:r>
+              <a:rPr kumimoji="0" lang="en-LK" altLang="en-LK" sz="1200" b="1" i="0" u="none" strike="noStrike" cap="none" normalizeH="0" baseline="0" dirty="0">
+                <a:ln>
+                  <a:noFill/>
+                </a:ln>
+                <a:effectLst/>
+                <a:latin typeface="+mn-lt"/>
+              </a:rPr>
+              <a:t>What this means:</a:t>
+            </a:r>
+            <a:endParaRPr kumimoji="0" lang="en-LK" altLang="en-LK" sz="1200" b="0" i="0" u="none" strike="noStrike" cap="none" normalizeH="0" baseline="0" dirty="0">
+              <a:ln>
+                <a:noFill/>
+              </a:ln>
+              <a:effectLst/>
+              <a:latin typeface="+mn-lt"/>
+            </a:endParaRPr>
+          </a:p>
+          <a:p>
+            <a:pPr marL="0" marR="0" lvl="0" indent="0" algn="just" defTabSz="914400" rtl="0" eaLnBrk="0" fontAlgn="base" latinLnBrk="0" hangingPunct="0">
+              <a:lnSpc>
+                <a:spcPct val="100000"/>
+              </a:lnSpc>
+              <a:spcBef>
+                <a:spcPct val="0"/>
+              </a:spcBef>
+              <a:spcAft>
+                <a:spcPct val="0"/>
+              </a:spcAft>
+              <a:buClrTx/>
+              <a:buSzTx/>
+              <a:buFontTx/>
+              <a:buNone/>
+              <a:tabLst/>
+            </a:pPr>
+            <a:r>
+              <a:rPr kumimoji="0" lang="en-LK" altLang="en-LK" sz="1200" b="0" i="0" u="none" strike="noStrike" cap="none" normalizeH="0" baseline="0" dirty="0">
+                <a:ln>
+                  <a:noFill/>
+                </a:ln>
+                <a:effectLst/>
+                <a:latin typeface="+mn-lt"/>
+              </a:rPr>
+              <a:t>The elite archive is clearly helping on most functions but hurting on highly multimodal problems like Rastrigin based ones (F5, F7, F8). </a:t>
+            </a:r>
+          </a:p>
+          <a:p>
+            <a:pPr marL="0" marR="0" lvl="0" indent="0" algn="just" defTabSz="914400" rtl="0" eaLnBrk="0" fontAlgn="base" latinLnBrk="0" hangingPunct="0">
+              <a:lnSpc>
+                <a:spcPct val="100000"/>
+              </a:lnSpc>
+              <a:spcBef>
+                <a:spcPct val="0"/>
+              </a:spcBef>
+              <a:spcAft>
+                <a:spcPct val="0"/>
+              </a:spcAft>
+              <a:buClrTx/>
+              <a:buSzTx/>
+              <a:buFontTx/>
+              <a:buNone/>
+              <a:tabLst/>
+            </a:pPr>
+            <a:r>
+              <a:rPr lang="en-GB" altLang="en-LK" sz="1200" dirty="0">
+                <a:latin typeface="+mn-lt"/>
+              </a:rPr>
+              <a:t>W</a:t>
+            </a:r>
+            <a:r>
+              <a:rPr lang="en-LK" altLang="en-LK" sz="1200" dirty="0">
+                <a:latin typeface="+mn-lt"/>
+              </a:rPr>
+              <a:t>hat to check withis is that t</a:t>
+            </a:r>
+            <a:r>
+              <a:rPr kumimoji="0" lang="en-LK" altLang="en-LK" sz="1200" b="0" i="0" u="none" strike="noStrike" cap="none" normalizeH="0" baseline="0" dirty="0">
+                <a:ln>
+                  <a:noFill/>
+                </a:ln>
+                <a:effectLst/>
+                <a:latin typeface="+mn-lt"/>
+              </a:rPr>
+              <a:t>he next thing to investigate would be whether adjusting p (archive fraction) helps on those failing functions which is a smaller archive (less freezing) might recover performance on F5/F7/F8/F15.</a:t>
+            </a:r>
+          </a:p>
+        </p:txBody>
+      </p:sp>
+    </p:spTree>
+    <p:extLst>
+      <p:ext uri="{BB962C8B-B14F-4D97-AF65-F5344CB8AC3E}">
+        <p14:creationId xmlns:p14="http://schemas.microsoft.com/office/powerpoint/2010/main" val="3615908325"/>
       </p:ext>
     </p:extLst>
   </p:cSld>

</xml_diff>